<commit_message>
James Stein Estimator updated
</commit_message>
<xml_diff>
--- a/James_Stein_Estimator.pptx
+++ b/James_Stein_Estimator.pptx
@@ -7,6 +7,7 @@
   <p:sldIdLst>
     <p:sldId id="256" r:id="rId2"/>
     <p:sldId id="257" r:id="rId3"/>
+    <p:sldId id="258" r:id="rId4"/>
   </p:sldIdLst>
   <p:sldSz cx="12192000" cy="6858000"/>
   <p:notesSz cx="6858000" cy="9144000"/>
@@ -105,6 +106,11 @@
       </a:defRPr>
     </a:lvl9pPr>
   </p:defaultTextStyle>
+  <p:extLst>
+    <p:ext uri="{EFAFB233-063F-42B5-8137-9DF3F51BA10A}">
+      <p15:sldGuideLst xmlns:p15="http://schemas.microsoft.com/office/powerpoint/2012/main"/>
+    </p:ext>
+  </p:extLst>
 </p:presentation>
 </file>
 
@@ -255,7 +261,7 @@
           <a:p>
             <a:fld id="{EE65A1C1-DAB8-144D-91BF-92D4901901FF}" type="datetimeFigureOut">
               <a:rPr lang="en-US" smtClean="0"/>
-              <a:t>2/27/20</a:t>
+              <a:t>3/2/20</a:t>
             </a:fld>
             <a:endParaRPr lang="en-US"/>
           </a:p>
@@ -453,7 +459,7 @@
           <a:p>
             <a:fld id="{EE65A1C1-DAB8-144D-91BF-92D4901901FF}" type="datetimeFigureOut">
               <a:rPr lang="en-US" smtClean="0"/>
-              <a:t>2/27/20</a:t>
+              <a:t>3/2/20</a:t>
             </a:fld>
             <a:endParaRPr lang="en-US"/>
           </a:p>
@@ -661,7 +667,7 @@
           <a:p>
             <a:fld id="{EE65A1C1-DAB8-144D-91BF-92D4901901FF}" type="datetimeFigureOut">
               <a:rPr lang="en-US" smtClean="0"/>
-              <a:t>2/27/20</a:t>
+              <a:t>3/2/20</a:t>
             </a:fld>
             <a:endParaRPr lang="en-US"/>
           </a:p>
@@ -859,7 +865,7 @@
           <a:p>
             <a:fld id="{EE65A1C1-DAB8-144D-91BF-92D4901901FF}" type="datetimeFigureOut">
               <a:rPr lang="en-US" smtClean="0"/>
-              <a:t>2/27/20</a:t>
+              <a:t>3/2/20</a:t>
             </a:fld>
             <a:endParaRPr lang="en-US"/>
           </a:p>
@@ -1134,7 +1140,7 @@
           <a:p>
             <a:fld id="{EE65A1C1-DAB8-144D-91BF-92D4901901FF}" type="datetimeFigureOut">
               <a:rPr lang="en-US" smtClean="0"/>
-              <a:t>2/27/20</a:t>
+              <a:t>3/2/20</a:t>
             </a:fld>
             <a:endParaRPr lang="en-US"/>
           </a:p>
@@ -1399,7 +1405,7 @@
           <a:p>
             <a:fld id="{EE65A1C1-DAB8-144D-91BF-92D4901901FF}" type="datetimeFigureOut">
               <a:rPr lang="en-US" smtClean="0"/>
-              <a:t>2/27/20</a:t>
+              <a:t>3/2/20</a:t>
             </a:fld>
             <a:endParaRPr lang="en-US"/>
           </a:p>
@@ -1811,7 +1817,7 @@
           <a:p>
             <a:fld id="{EE65A1C1-DAB8-144D-91BF-92D4901901FF}" type="datetimeFigureOut">
               <a:rPr lang="en-US" smtClean="0"/>
-              <a:t>2/27/20</a:t>
+              <a:t>3/2/20</a:t>
             </a:fld>
             <a:endParaRPr lang="en-US"/>
           </a:p>
@@ -1952,7 +1958,7 @@
           <a:p>
             <a:fld id="{EE65A1C1-DAB8-144D-91BF-92D4901901FF}" type="datetimeFigureOut">
               <a:rPr lang="en-US" smtClean="0"/>
-              <a:t>2/27/20</a:t>
+              <a:t>3/2/20</a:t>
             </a:fld>
             <a:endParaRPr lang="en-US"/>
           </a:p>
@@ -2065,7 +2071,7 @@
           <a:p>
             <a:fld id="{EE65A1C1-DAB8-144D-91BF-92D4901901FF}" type="datetimeFigureOut">
               <a:rPr lang="en-US" smtClean="0"/>
-              <a:t>2/27/20</a:t>
+              <a:t>3/2/20</a:t>
             </a:fld>
             <a:endParaRPr lang="en-US"/>
           </a:p>
@@ -2376,7 +2382,7 @@
           <a:p>
             <a:fld id="{EE65A1C1-DAB8-144D-91BF-92D4901901FF}" type="datetimeFigureOut">
               <a:rPr lang="en-US" smtClean="0"/>
-              <a:t>2/27/20</a:t>
+              <a:t>3/2/20</a:t>
             </a:fld>
             <a:endParaRPr lang="en-US"/>
           </a:p>
@@ -2664,7 +2670,7 @@
           <a:p>
             <a:fld id="{EE65A1C1-DAB8-144D-91BF-92D4901901FF}" type="datetimeFigureOut">
               <a:rPr lang="en-US" smtClean="0"/>
-              <a:t>2/27/20</a:t>
+              <a:t>3/2/20</a:t>
             </a:fld>
             <a:endParaRPr lang="en-US"/>
           </a:p>
@@ -2905,7 +2911,7 @@
           <a:p>
             <a:fld id="{EE65A1C1-DAB8-144D-91BF-92D4901901FF}" type="datetimeFigureOut">
               <a:rPr lang="en-US" smtClean="0"/>
-              <a:t>2/27/20</a:t>
+              <a:t>3/2/20</a:t>
             </a:fld>
             <a:endParaRPr lang="en-US"/>
           </a:p>
@@ -3337,7 +3343,7 @@
         <p:spPr>
           <a:xfrm>
             <a:off x="228599" y="823745"/>
-            <a:ext cx="9461091" cy="2862322"/>
+            <a:ext cx="9461091" cy="3139321"/>
           </a:xfrm>
           <a:prstGeom prst="rect">
             <a:avLst/>
@@ -3453,6 +3459,12 @@
             <a:r>
               <a:rPr lang="en-US" dirty="0"/>
               <a:t>  - nice clear explanation</a:t>
+            </a:r>
+          </a:p>
+          <a:p>
+            <a:r>
+              <a:rPr lang="en-US" dirty="0"/>
+              <a:t>Important Note: It doesn't work for 2 parameters, it should be 3 or more.</a:t>
             </a:r>
           </a:p>
         </p:txBody>
@@ -3588,7 +3600,7 @@
         </p:nvSpPr>
         <p:spPr>
           <a:xfrm>
-            <a:off x="228599" y="3888021"/>
+            <a:off x="228599" y="3995678"/>
             <a:ext cx="11643853" cy="2862322"/>
           </a:xfrm>
           <a:prstGeom prst="rect">
@@ -3921,6 +3933,374 @@
     <p:extLst>
       <p:ext uri="{BB962C8B-B14F-4D97-AF65-F5344CB8AC3E}">
         <p14:creationId xmlns:p14="http://schemas.microsoft.com/office/powerpoint/2010/main" val="3468902571"/>
+      </p:ext>
+    </p:extLst>
+  </p:cSld>
+  <p:clrMapOvr>
+    <a:masterClrMapping/>
+  </p:clrMapOvr>
+</p:sld>
+</file>
+
+<file path=ppt/slides/slide3.xml><?xml version="1.0" encoding="utf-8"?>
+<p:sld xmlns:a="http://schemas.openxmlformats.org/drawingml/2006/main" xmlns:r="http://schemas.openxmlformats.org/officeDocument/2006/relationships" xmlns:p="http://schemas.openxmlformats.org/presentationml/2006/main">
+  <p:cSld>
+    <p:spTree>
+      <p:nvGrpSpPr>
+        <p:cNvPr id="1" name=""/>
+        <p:cNvGrpSpPr/>
+        <p:nvPr/>
+      </p:nvGrpSpPr>
+      <p:grpSpPr>
+        <a:xfrm>
+          <a:off x="0" y="0"/>
+          <a:ext cx="0" cy="0"/>
+          <a:chOff x="0" y="0"/>
+          <a:chExt cx="0" cy="0"/>
+        </a:xfrm>
+      </p:grpSpPr>
+      <p:sp>
+        <p:nvSpPr>
+          <p:cNvPr id="4" name="TextBox 3">
+            <a:extLst>
+              <a:ext uri="{FF2B5EF4-FFF2-40B4-BE49-F238E27FC236}">
+                <a16:creationId xmlns:a16="http://schemas.microsoft.com/office/drawing/2014/main" id="{807FEDF4-E49C-B648-8D3A-845D2817CBD2}"/>
+              </a:ext>
+            </a:extLst>
+          </p:cNvPr>
+          <p:cNvSpPr txBox="1"/>
+          <p:nvPr/>
+        </p:nvSpPr>
+        <p:spPr>
+          <a:xfrm>
+            <a:off x="353962" y="1034197"/>
+            <a:ext cx="4616245" cy="369332"/>
+          </a:xfrm>
+          <a:prstGeom prst="rect">
+            <a:avLst/>
+          </a:prstGeom>
+          <a:noFill/>
+        </p:spPr>
+        <p:txBody>
+          <a:bodyPr wrap="square" rtlCol="0">
+            <a:spAutoFit/>
+          </a:bodyPr>
+          <a:lstStyle/>
+          <a:p>
+            <a:r>
+              <a:rPr lang="en-US" dirty="0">
+                <a:hlinkClick r:id="rId2"/>
+              </a:rPr>
+              <a:t>https://www.naftaliharris.com/blog/steinviz/</a:t>
+            </a:r>
+            <a:endParaRPr lang="en-US" dirty="0"/>
+          </a:p>
+        </p:txBody>
+      </p:sp>
+      <p:pic>
+        <p:nvPicPr>
+          <p:cNvPr id="5" name="Picture 4">
+            <a:extLst>
+              <a:ext uri="{FF2B5EF4-FFF2-40B4-BE49-F238E27FC236}">
+                <a16:creationId xmlns:a16="http://schemas.microsoft.com/office/drawing/2014/main" id="{45323EC6-A239-BD45-BEC3-15C0BB2C9206}"/>
+              </a:ext>
+            </a:extLst>
+          </p:cNvPr>
+          <p:cNvPicPr>
+            <a:picLocks noChangeAspect="1"/>
+          </p:cNvPicPr>
+          <p:nvPr/>
+        </p:nvPicPr>
+        <p:blipFill>
+          <a:blip r:embed="rId3" cstate="email">
+            <a:extLst>
+              <a:ext uri="{28A0092B-C50C-407E-A947-70E740481C1C}">
+                <a14:useLocalDpi xmlns:a14="http://schemas.microsoft.com/office/drawing/2010/main"/>
+              </a:ext>
+            </a:extLst>
+          </a:blip>
+          <a:stretch>
+            <a:fillRect/>
+          </a:stretch>
+        </p:blipFill>
+        <p:spPr>
+          <a:xfrm>
+            <a:off x="9794361" y="364994"/>
+            <a:ext cx="1614129" cy="1979998"/>
+          </a:xfrm>
+          <a:prstGeom prst="rect">
+            <a:avLst/>
+          </a:prstGeom>
+        </p:spPr>
+      </p:pic>
+      <p:sp>
+        <p:nvSpPr>
+          <p:cNvPr id="6" name="TextBox 5">
+            <a:extLst>
+              <a:ext uri="{FF2B5EF4-FFF2-40B4-BE49-F238E27FC236}">
+                <a16:creationId xmlns:a16="http://schemas.microsoft.com/office/drawing/2014/main" id="{5B6A79B6-4EDE-1948-815C-FE5AE9D2591D}"/>
+              </a:ext>
+            </a:extLst>
+          </p:cNvPr>
+          <p:cNvSpPr txBox="1"/>
+          <p:nvPr/>
+        </p:nvSpPr>
+        <p:spPr>
+          <a:xfrm>
+            <a:off x="9276735" y="2344992"/>
+            <a:ext cx="2741971" cy="2308324"/>
+          </a:xfrm>
+          <a:prstGeom prst="rect">
+            <a:avLst/>
+          </a:prstGeom>
+          <a:noFill/>
+        </p:spPr>
+        <p:txBody>
+          <a:bodyPr wrap="square" rtlCol="0">
+            <a:spAutoFit/>
+          </a:bodyPr>
+          <a:lstStyle/>
+          <a:p>
+            <a:r>
+              <a:rPr lang="en-US" dirty="0">
+                <a:hlinkClick r:id="rId4"/>
+              </a:rPr>
+              <a:t>Naftali.Harris@gmail.com</a:t>
+            </a:r>
+            <a:endParaRPr lang="en-US" dirty="0"/>
+          </a:p>
+          <a:p>
+            <a:endParaRPr lang="en-US" dirty="0">
+              <a:hlinkClick r:id="rId5"/>
+            </a:endParaRPr>
+          </a:p>
+          <a:p>
+            <a:r>
+              <a:rPr lang="en-US" dirty="0">
+                <a:hlinkClick r:id="rId6"/>
+              </a:rPr>
+              <a:t>https://www.sentilink.com/about/</a:t>
+            </a:r>
+            <a:endParaRPr lang="en-US" dirty="0"/>
+          </a:p>
+          <a:p>
+            <a:endParaRPr lang="en-US" dirty="0"/>
+          </a:p>
+          <a:p>
+            <a:r>
+              <a:rPr lang="en-US" dirty="0">
+                <a:hlinkClick r:id="rId7"/>
+              </a:rPr>
+              <a:t>https://www.naftaliharris.com/blog/ten-stat-ideas/</a:t>
+            </a:r>
+            <a:r>
+              <a:rPr lang="en-US" dirty="0"/>
+              <a:t> </a:t>
+            </a:r>
+          </a:p>
+          <a:p>
+            <a:endParaRPr lang="en-US" dirty="0"/>
+          </a:p>
+        </p:txBody>
+      </p:sp>
+      <p:sp>
+        <p:nvSpPr>
+          <p:cNvPr id="7" name="TextBox 6">
+            <a:extLst>
+              <a:ext uri="{FF2B5EF4-FFF2-40B4-BE49-F238E27FC236}">
+                <a16:creationId xmlns:a16="http://schemas.microsoft.com/office/drawing/2014/main" id="{ABB1AAF8-4C91-0A43-B91E-D14888B94E71}"/>
+              </a:ext>
+            </a:extLst>
+          </p:cNvPr>
+          <p:cNvSpPr txBox="1"/>
+          <p:nvPr/>
+        </p:nvSpPr>
+        <p:spPr>
+          <a:xfrm>
+            <a:off x="353962" y="189074"/>
+            <a:ext cx="6607277" cy="800219"/>
+          </a:xfrm>
+          <a:prstGeom prst="rect">
+            <a:avLst/>
+          </a:prstGeom>
+          <a:noFill/>
+        </p:spPr>
+        <p:txBody>
+          <a:bodyPr wrap="square" rtlCol="0">
+            <a:spAutoFit/>
+          </a:bodyPr>
+          <a:lstStyle/>
+          <a:p>
+            <a:r>
+              <a:rPr lang="en-US" sz="2800" b="1" dirty="0"/>
+              <a:t>Visualizing the James-Stein Estimator</a:t>
+            </a:r>
+          </a:p>
+          <a:p>
+            <a:r>
+              <a:rPr lang="en-US" dirty="0"/>
+              <a:t>by Naftali Harris, 2013</a:t>
+            </a:r>
+          </a:p>
+        </p:txBody>
+      </p:sp>
+      <p:pic>
+        <p:nvPicPr>
+          <p:cNvPr id="8" name="Picture 7">
+            <a:extLst>
+              <a:ext uri="{FF2B5EF4-FFF2-40B4-BE49-F238E27FC236}">
+                <a16:creationId xmlns:a16="http://schemas.microsoft.com/office/drawing/2014/main" id="{6F40216D-B1D2-2F4E-A9BD-CC54A81E322B}"/>
+              </a:ext>
+            </a:extLst>
+          </p:cNvPr>
+          <p:cNvPicPr>
+            <a:picLocks noChangeAspect="1"/>
+          </p:cNvPicPr>
+          <p:nvPr/>
+        </p:nvPicPr>
+        <p:blipFill>
+          <a:blip r:embed="rId8" cstate="email">
+            <a:extLst>
+              <a:ext uri="{28A0092B-C50C-407E-A947-70E740481C1C}">
+                <a14:useLocalDpi xmlns:a14="http://schemas.microsoft.com/office/drawing/2010/main"/>
+              </a:ext>
+            </a:extLst>
+          </a:blip>
+          <a:stretch>
+            <a:fillRect/>
+          </a:stretch>
+        </p:blipFill>
+        <p:spPr>
+          <a:xfrm>
+            <a:off x="353962" y="3495990"/>
+            <a:ext cx="5969000" cy="3061244"/>
+          </a:xfrm>
+          <a:prstGeom prst="rect">
+            <a:avLst/>
+          </a:prstGeom>
+        </p:spPr>
+      </p:pic>
+      <p:pic>
+        <p:nvPicPr>
+          <p:cNvPr id="9" name="Picture 8">
+            <a:extLst>
+              <a:ext uri="{FF2B5EF4-FFF2-40B4-BE49-F238E27FC236}">
+                <a16:creationId xmlns:a16="http://schemas.microsoft.com/office/drawing/2014/main" id="{EE9867C6-086D-E146-AF4B-8CF51307ACC2}"/>
+              </a:ext>
+            </a:extLst>
+          </p:cNvPr>
+          <p:cNvPicPr>
+            <a:picLocks noChangeAspect="1"/>
+          </p:cNvPicPr>
+          <p:nvPr/>
+        </p:nvPicPr>
+        <p:blipFill>
+          <a:blip r:embed="rId9" cstate="email">
+            <a:extLst>
+              <a:ext uri="{28A0092B-C50C-407E-A947-70E740481C1C}">
+                <a14:useLocalDpi xmlns:a14="http://schemas.microsoft.com/office/drawing/2010/main"/>
+              </a:ext>
+            </a:extLst>
+          </a:blip>
+          <a:stretch>
+            <a:fillRect/>
+          </a:stretch>
+        </p:blipFill>
+        <p:spPr>
+          <a:xfrm>
+            <a:off x="486698" y="1873766"/>
+            <a:ext cx="5346700" cy="1054100"/>
+          </a:xfrm>
+          <a:prstGeom prst="rect">
+            <a:avLst/>
+          </a:prstGeom>
+        </p:spPr>
+      </p:pic>
+      <p:sp>
+        <p:nvSpPr>
+          <p:cNvPr id="10" name="TextBox 9">
+            <a:extLst>
+              <a:ext uri="{FF2B5EF4-FFF2-40B4-BE49-F238E27FC236}">
+                <a16:creationId xmlns:a16="http://schemas.microsoft.com/office/drawing/2014/main" id="{7026508C-7D8D-7049-BD7D-1485959D3611}"/>
+              </a:ext>
+            </a:extLst>
+          </p:cNvPr>
+          <p:cNvSpPr txBox="1"/>
+          <p:nvPr/>
+        </p:nvSpPr>
+        <p:spPr>
+          <a:xfrm rot="20790127">
+            <a:off x="6620183" y="608028"/>
+            <a:ext cx="1519084" cy="369332"/>
+          </a:xfrm>
+          <a:prstGeom prst="rect">
+            <a:avLst/>
+          </a:prstGeom>
+          <a:noFill/>
+        </p:spPr>
+        <p:txBody>
+          <a:bodyPr wrap="square" rtlCol="0">
+            <a:spAutoFit/>
+          </a:bodyPr>
+          <a:lstStyle/>
+          <a:p>
+            <a:r>
+              <a:rPr lang="en-US" dirty="0"/>
+              <a:t>read this</a:t>
+            </a:r>
+          </a:p>
+        </p:txBody>
+      </p:sp>
+      <p:sp>
+        <p:nvSpPr>
+          <p:cNvPr id="11" name="Right Arrow 10">
+            <a:extLst>
+              <a:ext uri="{FF2B5EF4-FFF2-40B4-BE49-F238E27FC236}">
+                <a16:creationId xmlns:a16="http://schemas.microsoft.com/office/drawing/2014/main" id="{3E38CEFB-4703-D344-A5A0-4EFE1A4CD463}"/>
+              </a:ext>
+            </a:extLst>
+          </p:cNvPr>
+          <p:cNvSpPr/>
+          <p:nvPr/>
+        </p:nvSpPr>
+        <p:spPr>
+          <a:xfrm rot="10225705">
+            <a:off x="5021916" y="956288"/>
+            <a:ext cx="1504336" cy="324428"/>
+          </a:xfrm>
+          <a:prstGeom prst="rightArrow">
+            <a:avLst/>
+          </a:prstGeom>
+        </p:spPr>
+        <p:style>
+          <a:lnRef idx="2">
+            <a:schemeClr val="accent1">
+              <a:shade val="50000"/>
+            </a:schemeClr>
+          </a:lnRef>
+          <a:fillRef idx="1">
+            <a:schemeClr val="accent1"/>
+          </a:fillRef>
+          <a:effectRef idx="0">
+            <a:schemeClr val="accent1"/>
+          </a:effectRef>
+          <a:fontRef idx="minor">
+            <a:schemeClr val="lt1"/>
+          </a:fontRef>
+        </p:style>
+        <p:txBody>
+          <a:bodyPr rtlCol="0" anchor="ctr"/>
+          <a:lstStyle/>
+          <a:p>
+            <a:pPr algn="ctr"/>
+            <a:endParaRPr lang="en-US"/>
+          </a:p>
+        </p:txBody>
+      </p:sp>
+    </p:spTree>
+    <p:extLst>
+      <p:ext uri="{BB962C8B-B14F-4D97-AF65-F5344CB8AC3E}">
+        <p14:creationId xmlns:p14="http://schemas.microsoft.com/office/powerpoint/2010/main" val="1863281201"/>
       </p:ext>
     </p:extLst>
   </p:cSld>

</xml_diff>